<commit_message>
Add current-density and temperature-field figures to the poster
Two claims had no visual support: the electromagnetic dead-zone argument and
the temperature results. Adds ICEM Fig. 3 (current density) beside the AC-loss
chart at half column width each, and ECCE Fig. 9 (temperature fields at the
three optimal designs) under the optimal-size table, both with short captions.

Space comes from removing the 18x tile, which restated the table directly above
it, and trimming the Pareto plot. The AC-loss chart is adapted to its narrower
frame: shorter series names so the legend fits one row, 22 pt fonts, and the
rotated y-axis title dropped in favour of the caption since it collided with
the tick labels.

Co-Authored-By: Claude Opus 5 <noreply@anthropic.com>
Claude-Session: https://claude.ai/code/session_01EouduLSpmjyJpXzyEbnYj4
</commit_message>
<xml_diff>
--- a/poster-cooling-channel-shape/v2-condensed/HiECSs_08_2026_poster_condensed.pptx
+++ b/poster-cooling-channel-shape/v2-condensed/HiECSs_08_2026_poster_condensed.pptx
@@ -729,7 +729,7 @@
               <c:strCache>
                 <c:ptCount val="1"/>
                 <c:pt idx="0">
-                  <c:v>Round channel</c:v>
+                  <c:v>Round</c:v>
                 </c:pt>
               </c:strCache>
             </c:strRef>
@@ -797,7 +797,7 @@
               <c:strCache>
                 <c:ptCount val="1"/>
                 <c:pt idx="0">
-                  <c:v>Rectangular channel</c:v>
+                  <c:v>Rectangular</c:v>
                 </c:pt>
               </c:strCache>
             </c:strRef>
@@ -916,29 +916,6 @@
             </a:ln>
           </c:spPr>
         </c:majorGridlines>
-        <c:title>
-          <c:tx>
-            <c:rich>
-              <a:bodyPr/>
-              <a:lstStyle/>
-              <a:p>
-                <a:pPr>
-                  <a:defRPr b="0"/>
-                </a:pPr>
-                <a:r>
-                  <a:rPr lang="en-US" b="0" noProof="0" dirty="0"/>
-                  <a:t>Loss</a:t>
-                </a:r>
-                <a:r>
-                  <a:rPr lang="en-US" b="0" baseline="0" noProof="0" dirty="0"/>
-                  <a:t> (W)</a:t>
-                </a:r>
-                <a:endParaRPr lang="en-US" b="0" noProof="0" dirty="0"/>
-              </a:p>
-            </c:rich>
-          </c:tx>
-          <c:overlay val="0"/>
-        </c:title>
         <c:numFmt formatCode="#,##0" sourceLinked="0"/>
         <c:majorTickMark val="out"/>
         <c:minorTickMark val="none"/>
@@ -973,7 +950,7 @@
         <a:lstStyle/>
         <a:p>
           <a:pPr>
-            <a:defRPr sz="3000"/>
+            <a:defRPr sz="2200"/>
           </a:pPr>
           <a:endParaRPr lang="en-US"/>
         </a:p>
@@ -995,7 +972,7 @@
     <a:lstStyle/>
     <a:p>
       <a:pPr>
-        <a:defRPr sz="2400">
+        <a:defRPr sz="2200">
           <a:latin typeface="Times New Roman" panose="02020603050405020304" pitchFamily="18" charset="0"/>
           <a:cs typeface="Times New Roman" panose="02020603050405020304" pitchFamily="18" charset="0"/>
         </a:defRPr>
@@ -2032,7 +2009,7 @@
         </p:nvSpPr>
         <p:spPr>
           <a:xfrm>
-            <a:off x="2039112" y="14827087"/>
+            <a:off x="2039112" y="14830379"/>
             <a:ext cx="12179808" cy="1060704"/>
           </a:xfrm>
           <a:prstGeom prst="rect">
@@ -2077,7 +2054,7 @@
         </p:nvSpPr>
         <p:spPr>
           <a:xfrm>
-            <a:off x="7342392" y="17103029"/>
+            <a:off x="7342392" y="17106320"/>
             <a:ext cx="6876527" cy="6736575"/>
           </a:xfrm>
           <a:prstGeom prst="rect">
@@ -2191,7 +2168,7 @@
         </p:nvSpPr>
         <p:spPr>
           <a:xfrm>
-            <a:off x="2039112" y="23022854"/>
+            <a:off x="2039112" y="23029529"/>
             <a:ext cx="12179808" cy="1060704"/>
           </a:xfrm>
           <a:prstGeom prst="rect">
@@ -2243,7 +2220,7 @@
           </p:nvPr>
         </p:nvGraphicFramePr>
         <p:xfrm>
-          <a:off x="2039112" y="24166494"/>
+          <a:off x="2039112" y="24173169"/>
           <a:ext cx="12179808" cy="3950208"/>
         </p:xfrm>
         <a:graphic>
@@ -3022,7 +2999,7 @@
         </p:nvSpPr>
         <p:spPr>
           <a:xfrm>
-            <a:off x="2039112" y="28768121"/>
+            <a:off x="2039112" y="28778179"/>
             <a:ext cx="12179808" cy="585216"/>
           </a:xfrm>
           <a:prstGeom prst="rect">
@@ -3067,7 +3044,7 @@
         </p:nvSpPr>
         <p:spPr>
           <a:xfrm>
-            <a:off x="2039112" y="29911669"/>
+            <a:off x="2039112" y="29921728"/>
             <a:ext cx="12179808" cy="2498852"/>
           </a:xfrm>
           <a:prstGeom prst="rect">
@@ -3175,8 +3152,8 @@
           </p:nvPr>
         </p:nvGraphicFramePr>
         <p:xfrm>
-          <a:off x="2039112" y="32738811"/>
-          <a:ext cx="12179808" cy="4069080"/>
+          <a:off x="8461857" y="32748870"/>
+          <a:ext cx="5757062" cy="3474720"/>
         </p:xfrm>
         <a:graphic>
           <a:graphicData uri="http://schemas.openxmlformats.org/drawingml/2006/chart">
@@ -3401,8 +3378,8 @@
         </p:blipFill>
         <p:spPr>
           <a:xfrm>
-            <a:off x="16138428" y="19425513"/>
-            <a:ext cx="11724071" cy="6455206"/>
+            <a:off x="17433401" y="19373850"/>
+            <a:ext cx="9134124" cy="5029200"/>
           </a:xfrm>
           <a:prstGeom prst="rect">
             <a:avLst/>
@@ -3424,7 +3401,7 @@
           </p:nvPr>
         </p:nvGraphicFramePr>
         <p:xfrm>
-          <a:off x="15764255" y="26473068"/>
+          <a:off x="15764255" y="24943734"/>
           <a:ext cx="12472416" cy="2633472"/>
         </p:xfrm>
         <a:graphic>
@@ -4317,126 +4294,6 @@
           </a:graphicData>
         </a:graphic>
       </p:graphicFrame>
-      <p:sp>
-        <p:nvSpPr>
-          <p:cNvPr id="48" name="Shape 35"/>
-          <p:cNvSpPr/>
-          <p:nvPr/>
-        </p:nvSpPr>
-        <p:spPr>
-          <a:xfrm>
-            <a:off x="15764255" y="29698889"/>
-            <a:ext cx="12472416" cy="2103120"/>
-          </a:xfrm>
-          <a:prstGeom prst="roundRect">
-            <a:avLst>
-              <a:gd name="adj" fmla="val 5000"/>
-            </a:avLst>
-          </a:prstGeom>
-          <a:solidFill>
-            <a:srgbClr val="FFF1E8"/>
-          </a:solidFill>
-          <a:ln/>
-        </p:spPr>
-        <p:txBody>
-          <a:bodyPr/>
-          <a:lstStyle/>
-          <a:p>
-            <a:pPr algn="just"/>
-            <a:endParaRPr lang="en-US" noProof="0" dirty="0">
-              <a:latin typeface="Times New Roman" panose="02020603050405020304" pitchFamily="18" charset="0"/>
-              <a:cs typeface="Times New Roman" panose="02020603050405020304" pitchFamily="18" charset="0"/>
-            </a:endParaRPr>
-          </a:p>
-        </p:txBody>
-      </p:sp>
-      <p:sp>
-        <p:nvSpPr>
-          <p:cNvPr id="49" name="Text 36"/>
-          <p:cNvSpPr/>
-          <p:nvPr/>
-        </p:nvSpPr>
-        <p:spPr>
-          <a:xfrm>
-            <a:off x="16358616" y="29927489"/>
-            <a:ext cx="3479932" cy="1645920"/>
-          </a:xfrm>
-          <a:prstGeom prst="rect">
-            <a:avLst/>
-          </a:prstGeom>
-          <a:noFill/>
-          <a:ln/>
-        </p:spPr>
-        <p:txBody>
-          <a:bodyPr wrap="square" lIns="0" tIns="0" rIns="0" bIns="0" rtlCol="0" anchor="ctr"/>
-          <a:lstStyle/>
-          <a:p>
-            <a:pPr marL="0" indent="0" algn="just">
-              <a:buNone/>
-            </a:pPr>
-            <a:r>
-              <a:rPr lang="en-US" sz="7200" b="1" noProof="0" dirty="0">
-                <a:solidFill>
-                  <a:srgbClr val="E85D00"/>
-                </a:solidFill>
-                <a:latin typeface="Times New Roman" panose="02020603050405020304" pitchFamily="18" charset="0"/>
-                <a:ea typeface="Arial" pitchFamily="34" charset="-122"/>
-                <a:cs typeface="Times New Roman" panose="02020603050405020304" pitchFamily="18" charset="0"/>
-              </a:rPr>
-              <a:t>18 ×</a:t>
-            </a:r>
-            <a:endParaRPr lang="en-US" sz="7200" noProof="0" dirty="0">
-              <a:latin typeface="Times New Roman" panose="02020603050405020304" pitchFamily="18" charset="0"/>
-              <a:cs typeface="Times New Roman" panose="02020603050405020304" pitchFamily="18" charset="0"/>
-            </a:endParaRPr>
-          </a:p>
-        </p:txBody>
-      </p:sp>
-      <p:sp>
-        <p:nvSpPr>
-          <p:cNvPr id="50" name="Text 37"/>
-          <p:cNvSpPr/>
-          <p:nvPr/>
-        </p:nvSpPr>
-        <p:spPr>
-          <a:xfrm>
-            <a:off x="19092672" y="30443210"/>
-            <a:ext cx="8906256" cy="1389888"/>
-          </a:xfrm>
-          <a:prstGeom prst="rect">
-            <a:avLst/>
-          </a:prstGeom>
-          <a:noFill/>
-          <a:ln/>
-        </p:spPr>
-        <p:txBody>
-          <a:bodyPr wrap="square" lIns="0" tIns="0" rIns="0" bIns="0" rtlCol="0" anchor="ctr"/>
-          <a:lstStyle/>
-          <a:p>
-            <a:pPr marL="0" indent="0" algn="l">
-              <a:lnSpc>
-                <a:spcPct val="108000"/>
-              </a:lnSpc>
-              <a:buNone/>
-            </a:pPr>
-            <a:r>
-              <a:rPr lang="en-US" sz="3600" noProof="0" dirty="0">
-                <a:solidFill>
-                  <a:srgbClr val="3B3B3B"/>
-                </a:solidFill>
-                <a:latin typeface="Times New Roman" panose="02020603050405020304" pitchFamily="18" charset="0"/>
-                <a:ea typeface="Arial" pitchFamily="34" charset="-122"/>
-                <a:cs typeface="Times New Roman" panose="02020603050405020304" pitchFamily="18" charset="0"/>
-              </a:rPr>
-              <a:t>less pumping power, −48.6 °C vs. circular</a:t>
-            </a:r>
-            <a:endParaRPr lang="en-US" sz="3600" noProof="0" dirty="0">
-              <a:latin typeface="Times New Roman" panose="02020603050405020304" pitchFamily="18" charset="0"/>
-              <a:cs typeface="Times New Roman" panose="02020603050405020304" pitchFamily="18" charset="0"/>
-            </a:endParaRPr>
-          </a:p>
-        </p:txBody>
-      </p:sp>
       <p:sp>
         <p:nvSpPr>
           <p:cNvPr id="53" name="Text 39"/>
@@ -4873,7 +4730,7 @@
         </p:blipFill>
         <p:spPr>
           <a:xfrm>
-            <a:off x="2223794" y="15970636"/>
+            <a:off x="2223794" y="15974019"/>
             <a:ext cx="4754640" cy="6400800"/>
           </a:xfrm>
           <a:prstGeom prst="rect">
@@ -4902,7 +4759,7 @@
         </p:blipFill>
         <p:spPr>
           <a:xfrm>
-            <a:off x="15764255" y="15646024"/>
+            <a:off x="15764255" y="15594360"/>
             <a:ext cx="12472416" cy="3368009"/>
           </a:xfrm>
           <a:prstGeom prst="rect">
@@ -4910,6 +4767,156 @@
           </a:prstGeom>
         </p:spPr>
       </p:pic>
+      <p:pic>
+        <p:nvPicPr>
+          <p:cNvPr id="68" name="Picture 67" descr="icem_fig3_currentdensity.png"/>
+          <p:cNvPicPr>
+            <a:picLocks noChangeAspect="1"/>
+          </p:cNvPicPr>
+          <p:nvPr/>
+        </p:nvPicPr>
+        <p:blipFill>
+          <a:blip r:embed="rId10"/>
+          <a:stretch>
+            <a:fillRect/>
+          </a:stretch>
+        </p:blipFill>
+        <p:spPr>
+          <a:xfrm>
+            <a:off x="2039112" y="32748870"/>
+            <a:ext cx="6056960" cy="3474720"/>
+          </a:xfrm>
+          <a:prstGeom prst="rect">
+            <a:avLst/>
+          </a:prstGeom>
+        </p:spPr>
+      </p:pic>
+      <p:sp>
+        <p:nvSpPr>
+          <p:cNvPr id="69" name="TextBox 68"/>
+          <p:cNvSpPr txBox="1"/>
+          <p:nvPr/>
+        </p:nvSpPr>
+        <p:spPr>
+          <a:xfrm>
+            <a:off x="2039112" y="36315030"/>
+            <a:ext cx="6056960" cy="489508"/>
+          </a:xfrm>
+          <a:prstGeom prst="rect">
+            <a:avLst/>
+          </a:prstGeom>
+          <a:noFill/>
+        </p:spPr>
+        <p:txBody>
+          <a:bodyPr wrap="square" lIns="0" rIns="0" tIns="0" bIns="0">
+            <a:spAutoFit/>
+          </a:bodyPr>
+          <a:lstStyle/>
+          <a:p>
+            <a:r>
+              <a:rPr sz="2600" i="1">
+                <a:solidFill>
+                  <a:srgbClr val="595959"/>
+                </a:solidFill>
+                <a:latin typeface="Times New Roman"/>
+              </a:rPr>
+              <a:t>(a) solid   (b) round   (c) rectangular</a:t>
+            </a:r>
+          </a:p>
+        </p:txBody>
+      </p:sp>
+      <p:sp>
+        <p:nvSpPr>
+          <p:cNvPr id="70" name="TextBox 69"/>
+          <p:cNvSpPr txBox="1"/>
+          <p:nvPr/>
+        </p:nvSpPr>
+        <p:spPr>
+          <a:xfrm>
+            <a:off x="8461857" y="36315030"/>
+            <a:ext cx="5757088" cy="489508"/>
+          </a:xfrm>
+          <a:prstGeom prst="rect">
+            <a:avLst/>
+          </a:prstGeom>
+          <a:noFill/>
+        </p:spPr>
+        <p:txBody>
+          <a:bodyPr wrap="square" lIns="0" rIns="0" tIns="0" bIns="0">
+            <a:spAutoFit/>
+          </a:bodyPr>
+          <a:lstStyle/>
+          <a:p>
+            <a:r>
+              <a:rPr sz="2600" i="1">
+                <a:solidFill>
+                  <a:srgbClr val="595959"/>
+                </a:solidFill>
+                <a:latin typeface="Times New Roman"/>
+              </a:rPr>
+              <a:t>AC loss per layer (W)</a:t>
+            </a:r>
+          </a:p>
+        </p:txBody>
+      </p:sp>
+      <p:pic>
+        <p:nvPicPr>
+          <p:cNvPr id="71" name="Picture 70" descr="ecce_fig9_tempmaps.png"/>
+          <p:cNvPicPr>
+            <a:picLocks noChangeAspect="1"/>
+          </p:cNvPicPr>
+          <p:nvPr/>
+        </p:nvPicPr>
+        <p:blipFill>
+          <a:blip r:embed="rId11"/>
+          <a:stretch>
+            <a:fillRect/>
+          </a:stretch>
+        </p:blipFill>
+        <p:spPr>
+          <a:xfrm>
+            <a:off x="15764255" y="28117891"/>
+            <a:ext cx="12472416" cy="3154862"/>
+          </a:xfrm>
+          <a:prstGeom prst="rect">
+            <a:avLst/>
+          </a:prstGeom>
+        </p:spPr>
+      </p:pic>
+      <p:sp>
+        <p:nvSpPr>
+          <p:cNvPr id="72" name="TextBox 71"/>
+          <p:cNvSpPr txBox="1"/>
+          <p:nvPr/>
+        </p:nvSpPr>
+        <p:spPr>
+          <a:xfrm>
+            <a:off x="15764255" y="31364194"/>
+            <a:ext cx="12472416" cy="489508"/>
+          </a:xfrm>
+          <a:prstGeom prst="rect">
+            <a:avLst/>
+          </a:prstGeom>
+          <a:noFill/>
+        </p:spPr>
+        <p:txBody>
+          <a:bodyPr wrap="square" lIns="0" rIns="0" tIns="0" bIns="0">
+            <a:spAutoFit/>
+          </a:bodyPr>
+          <a:lstStyle/>
+          <a:p>
+            <a:r>
+              <a:rPr sz="2600" i="1">
+                <a:solidFill>
+                  <a:srgbClr val="595959"/>
+                </a:solidFill>
+                <a:latin typeface="Times New Roman"/>
+              </a:rPr>
+              <a:t>Optimal designs: (a) circular   (b) rectangular   (c) elliptical</a:t>
+            </a:r>
+          </a:p>
+        </p:txBody>
+      </p:sp>
     </p:spTree>
   </p:cSld>
   <p:clrMapOvr>

</xml_diff>